<commit_message>
Workflow figure minor update
</commit_message>
<xml_diff>
--- a/plots/workflow.pptx
+++ b/plots/workflow.pptx
@@ -3844,6 +3844,10 @@
             </a:endParaRPr>
           </a:p>
           <a:p>
+            <a:pPr marL="457200" indent="-457200">
+              <a:buFontTx/>
+              <a:buChar char="-"/>
+            </a:pPr>
             <a:r>
               <a:rPr lang="en-US" sz="2800" dirty="0">
                 <a:solidFill>
@@ -3857,6 +3861,10 @@
             </a:r>
           </a:p>
           <a:p>
+            <a:pPr marL="457200" indent="-457200">
+              <a:buFontTx/>
+              <a:buChar char="-"/>
+            </a:pPr>
             <a:r>
               <a:rPr lang="en-US" sz="2800" dirty="0">
                 <a:solidFill>
@@ -3866,10 +3874,36 @@
                 <a:ea typeface="EB Garamond Medium" pitchFamily="2" charset="0"/>
                 <a:cs typeface="EB Garamond Medium" pitchFamily="2" charset="0"/>
               </a:rPr>
-              <a:t>Null hypothesis tests</a:t>
-            </a:r>
-          </a:p>
-          <a:p>
+              <a:t>Null </a:t>
+            </a:r>
+            <a:r>
+              <a:rPr lang="en-US" sz="2800">
+                <a:solidFill>
+                  <a:schemeClr val="tx1"/>
+                </a:solidFill>
+                <a:latin typeface="EB Garamond Medium" pitchFamily="2" charset="0"/>
+                <a:ea typeface="EB Garamond Medium" pitchFamily="2" charset="0"/>
+                <a:cs typeface="EB Garamond Medium" pitchFamily="2" charset="0"/>
+              </a:rPr>
+              <a:t>hypothesis tests</a:t>
+            </a:r>
+          </a:p>
+          <a:p>
+            <a:pPr marL="457200" indent="-457200">
+              <a:buFontTx/>
+              <a:buChar char="-"/>
+            </a:pPr>
+            <a:r>
+              <a:rPr lang="en-US" sz="2800">
+                <a:solidFill>
+                  <a:schemeClr val="tx1"/>
+                </a:solidFill>
+                <a:latin typeface="EB Garamond Medium" pitchFamily="2" charset="0"/>
+                <a:ea typeface="EB Garamond Medium" pitchFamily="2" charset="0"/>
+                <a:cs typeface="EB Garamond Medium" pitchFamily="2" charset="0"/>
+              </a:rPr>
+              <a:t>Equivalence </a:t>
+            </a:r>
             <a:r>
               <a:rPr lang="en-US" sz="2800" dirty="0">
                 <a:solidFill>
@@ -3879,7 +3913,7 @@
                 <a:ea typeface="EB Garamond Medium" pitchFamily="2" charset="0"/>
                 <a:cs typeface="EB Garamond Medium" pitchFamily="2" charset="0"/>
               </a:rPr>
-              <a:t>Equivalence tests</a:t>
+              <a:t>tests</a:t>
             </a:r>
           </a:p>
         </p:txBody>

</xml_diff>